<commit_message>
Website: real team, achievements, and a UzCombinator page
- Team: 5 real founders with photos, names and roles (replaces placeholders)
  — Zaxro (CEO), Dilshod (Data Scientist), Shohruh (Full-stack), Nodirbek
  (UI/UX), Dilshoda (Data Analyst); uz/ru/en
- Achievements section: two hackathon wins with photos — EdTech 2026 (1st,
  team Nova) and Green Tech 2025 (2nd, team FEBA); uz/ru/en
- /uzcombinator page: a focused UzCombinator application page in the FoodGPT
  design language (hero, traction badges, problem/solution, team, links,
  "why now") with live app links; static in all 3 locales
- Photos under website/public/{team,achievements}

Co-Authored-By: Claude Opus 4.8 <noreply@anthropic.com>
</commit_message>
<xml_diff>
--- a/FoodGPT-taqdimot.pptx
+++ b/FoodGPT-taqdimot.pptx
@@ -3486,7 +3486,7 @@
                 </a:solidFill>
                 <a:latin typeface="Segoe UI"/>
               </a:rPr>
-              <a:t>AI orqali yaqin, ochiq va sizga mos restoranni topadi — bron, navigatsiya, taxi bir oqimda. O'zbekiston uchun.</a:t>
+              <a:t>AI orqali yaqin, ochiq va sizga mos ovqatlanish joyini topadi — bron, navigatsiya, taxi bir oqimda. O'zbekiston uchun.</a:t>
             </a:r>
           </a:p>
         </p:txBody>
@@ -3500,7 +3500,7 @@
         <p:spPr>
           <a:xfrm>
             <a:off x="841248" y="5623560"/>
-            <a:ext cx="3749039" cy="402336"/>
+            <a:ext cx="4704588" cy="402336"/>
           </a:xfrm>
           <a:prstGeom prst="roundRect">
             <a:avLst>
@@ -3541,7 +3541,7 @@
                 </a:solidFill>
                 <a:latin typeface="Segoe UI"/>
               </a:rPr>
-              <a:t>Restoran discovery + bron infratuzilmasi</a:t>
+              <a:t>Ovqatlanish joylari discovery + bron infratuzilmasi</a:t>
             </a:r>
           </a:p>
         </p:txBody>
@@ -3554,7 +3554,7 @@
         </p:nvSpPr>
         <p:spPr>
           <a:xfrm>
-            <a:off x="4736592" y="5623560"/>
+            <a:off x="5692140" y="5623560"/>
             <a:ext cx="2185415" cy="402336"/>
           </a:xfrm>
           <a:prstGeom prst="roundRect">
@@ -4163,7 +4163,7 @@
                 </a:solidFill>
                 <a:latin typeface="Segoe UI"/>
               </a:rPr>
-              <a:t>Restoranlar (hamkor)</a:t>
+              <a:t>Ovqatlanish joylari (obuna)</a:t>
             </a:r>
           </a:p>
         </p:txBody>
@@ -4835,7 +4835,7 @@
                 </a:solidFill>
                 <a:latin typeface="Segoe UI"/>
               </a:rPr>
-              <a:t>Daromad (yillik)</a:t>
+              <a:t>Daromad (obuna+komissiya)</a:t>
             </a:r>
           </a:p>
         </p:txBody>
@@ -4880,7 +4880,7 @@
                 </a:solidFill>
                 <a:latin typeface="Segoe UI"/>
               </a:rPr>
-              <a:t>$0.1M</a:t>
+              <a:t>$0.15M</a:t>
             </a:r>
           </a:p>
         </p:txBody>
@@ -4925,7 +4925,7 @@
                 </a:solidFill>
                 <a:latin typeface="Segoe UI"/>
               </a:rPr>
-              <a:t>$1.2M</a:t>
+              <a:t>$1.6M</a:t>
             </a:r>
           </a:p>
         </p:txBody>
@@ -4970,7 +4970,7 @@
                 </a:solidFill>
                 <a:latin typeface="Segoe UI"/>
               </a:rPr>
-              <a:t>$6M</a:t>
+              <a:t>$8M</a:t>
             </a:r>
           </a:p>
         </p:txBody>
@@ -5444,7 +5444,7 @@
                 </a:solidFill>
                 <a:latin typeface="Segoe UI"/>
               </a:rPr>
-              <a:t>18 oylik yo'lni moliyalashtirish: backend + mijozlar, restoran onboarding, jamoa va Toshkentda ishga tushirish.</a:t>
+              <a:t>18 oylik yo'lni moliyalashtirish: backend + mijozlar, ovqatlanish joyi onboarding, jamoa va Toshkentda ishga tushirish.</a:t>
             </a:r>
           </a:p>
         </p:txBody>
@@ -5624,7 +5624,7 @@
                 </a:solidFill>
                 <a:latin typeface="Segoe UI"/>
               </a:rPr>
-              <a:t>30% — restoran onboarding (sales/ops)</a:t>
+              <a:t>30% — ovqatlanish joyi onboarding (sales/ops)</a:t>
             </a:r>
           </a:p>
         </p:txBody>
@@ -7109,7 +7109,7 @@
                 </a:solidFill>
                 <a:latin typeface="Segoe UI"/>
               </a:rPr>
-              <a:t>O'zbekistonda barcha restoranlarni birlashtirgan yagona joy yo'q. Odam Google Maps'ga kirib ovqat izlamaydi.</a:t>
+              <a:t>O'zbekistonda barcha ovqatlanish joylarini birlashtirgan yagona joy yo'q. Odam Google Maps'ga kirib ovqat izlamaydi.</a:t>
             </a:r>
           </a:p>
         </p:txBody>
@@ -8319,7 +8319,61 @@
       </p:sp>
       <p:sp>
         <p:nvSpPr>
-          <p:cNvPr id="17" name="Rectangle 16"/>
+          <p:cNvPr id="17" name="TextBox 16"/>
+          <p:cNvSpPr txBox="1"/>
+          <p:nvPr/>
+        </p:nvSpPr>
+        <p:spPr>
+          <a:xfrm>
+            <a:off x="685800" y="5897880"/>
+            <a:ext cx="10789920" cy="457200"/>
+          </a:xfrm>
+          <a:prstGeom prst="rect">
+            <a:avLst/>
+          </a:prstGeom>
+          <a:noFill/>
+        </p:spPr>
+        <p:txBody>
+          <a:bodyPr wrap="square" anchor="t" lIns="0" rIns="0" tIns="0" bIns="0">
+            <a:spAutoFit/>
+          </a:bodyPr>
+          <a:lstStyle/>
+          <a:p>
+            <a:pPr algn="l">
+              <a:lnSpc>
+                <a:spcPct val="100000"/>
+              </a:lnSpc>
+              <a:spcBef>
+                <a:spcPts val="0"/>
+              </a:spcBef>
+              <a:spcAft>
+                <a:spcPts val="400"/>
+              </a:spcAft>
+            </a:pPr>
+            <a:r>
+              <a:rPr sz="1200" b="0">
+                <a:solidFill>
+                  <a:srgbClr val="6B6259"/>
+                </a:solidFill>
+                <a:latin typeface="Segoe UI"/>
+              </a:rPr>
+              <a:t>Barcha ovqatlanish joylari: </a:t>
+            </a:r>
+            <a:r>
+              <a:rPr sz="1200" b="1">
+                <a:solidFill>
+                  <a:srgbClr val="1A1410"/>
+                </a:solidFill>
+                <a:latin typeface="Segoe UI"/>
+              </a:rPr>
+              <a:t>restoran · kafe · choyxona · milliy oshxona · fastfud · kabob/osh markazlari</a:t>
+            </a:r>
+          </a:p>
+        </p:txBody>
+      </p:sp>
+      <p:sp>
+        <p:nvSpPr>
+          <p:cNvPr id="18" name="Rectangle 17"/>
           <p:cNvSpPr/>
           <p:nvPr/>
         </p:nvSpPr>
@@ -9631,7 +9685,7 @@
                 </a:solidFill>
                 <a:latin typeface="Segoe UI"/>
               </a:rPr>
-              <a:t>O'zbekiston restoran/HoReCa bozori (TAM) </a:t>
+              <a:t>O'zbekiston ovqatlanish/HoReCa bozori (TAM) </a:t>
             </a:r>
             <a:r>
               <a:rPr sz="1100" b="1">
@@ -9685,7 +9739,7 @@
                 </a:solidFill>
                 <a:latin typeface="Segoe UI"/>
               </a:rPr>
-              <a:t>30K+</a:t>
+              <a:t>50K+</a:t>
             </a:r>
           </a:p>
         </p:txBody>
@@ -9730,7 +9784,7 @@
                 </a:solidFill>
                 <a:latin typeface="Segoe UI"/>
               </a:rPr>
-              <a:t>Restoran, kafe, choyxona (SAM) </a:t>
+              <a:t>Restoran, kafe, choyxona, oshxona, fastfud (SAM) </a:t>
             </a:r>
             <a:r>
               <a:rPr sz="1100" b="1">
@@ -10942,7 +10996,7 @@
                 </a:solidFill>
                 <a:latin typeface="Segoe UI"/>
               </a:rPr>
-              <a:t>Real-time restoran data + bron infratuzilmasi (OpenTable yo'li)</a:t>
+              <a:t>Real-time ovqatlanish joyi data + bron infratuzilmasi (OpenTable yo'li)</a:t>
             </a:r>
           </a:p>
         </p:txBody>
@@ -12972,13 +13026,13 @@
               </a:spcAft>
             </a:pPr>
             <a:r>
-              <a:rPr sz="2600" b="1">
+              <a:rPr sz="2500" b="1">
                 <a:solidFill>
                   <a:srgbClr val="1A1410"/>
                 </a:solidFill>
                 <a:latin typeface="Segoe UI"/>
               </a:rPr>
-              <a:t>Restorandan komissiya, foydalanuvchiga bepul</a:t>
+              <a:t>Gibrid: oylik obuna + komissiya. Foydalanuvchiga bepul.</a:t>
             </a:r>
           </a:p>
         </p:txBody>
@@ -12992,7 +13046,245 @@
         <p:spPr>
           <a:xfrm>
             <a:off x="685800" y="2926080"/>
-            <a:ext cx="3429000" cy="2468880"/>
+            <a:ext cx="3429000" cy="2606040"/>
+          </a:xfrm>
+          <a:prstGeom prst="roundRect">
+            <a:avLst>
+              <a:gd name="adj" fmla="val 9000"/>
+            </a:avLst>
+          </a:prstGeom>
+          <a:solidFill>
+            <a:srgbClr val="FFFFFF"/>
+          </a:solidFill>
+          <a:ln w="20320">
+            <a:solidFill>
+              <a:srgbClr val="FF6B35"/>
+            </a:solidFill>
+          </a:ln>
+          <a:effectLst/>
+        </p:spPr>
+        <p:style>
+          <a:lnRef idx="1">
+            <a:schemeClr val="accent1"/>
+          </a:lnRef>
+          <a:fillRef idx="3">
+            <a:schemeClr val="accent1"/>
+          </a:fillRef>
+          <a:effectRef idx="2">
+            <a:schemeClr val="accent1"/>
+          </a:effectRef>
+          <a:fontRef idx="minor">
+            <a:schemeClr val="lt1"/>
+          </a:fontRef>
+        </p:style>
+        <p:txBody>
+          <a:bodyPr rtlCol="0" anchor="ctr"/>
+          <a:lstStyle/>
+          <a:p>
+            <a:pPr algn="ctr"/>
+          </a:p>
+        </p:txBody>
+      </p:sp>
+      <p:sp>
+        <p:nvSpPr>
+          <p:cNvPr id="9" name="TextBox 8"/>
+          <p:cNvSpPr txBox="1"/>
+          <p:nvPr/>
+        </p:nvSpPr>
+        <p:spPr>
+          <a:xfrm>
+            <a:off x="978408" y="3182112"/>
+            <a:ext cx="2834640" cy="457200"/>
+          </a:xfrm>
+          <a:prstGeom prst="rect">
+            <a:avLst/>
+          </a:prstGeom>
+          <a:noFill/>
+        </p:spPr>
+        <p:txBody>
+          <a:bodyPr wrap="square" anchor="t" lIns="0" rIns="0" tIns="0" bIns="0">
+            <a:spAutoFit/>
+          </a:bodyPr>
+          <a:lstStyle/>
+          <a:p>
+            <a:pPr algn="l">
+              <a:lnSpc>
+                <a:spcPct val="100000"/>
+              </a:lnSpc>
+              <a:spcBef>
+                <a:spcPts val="0"/>
+              </a:spcBef>
+              <a:spcAft>
+                <a:spcPts val="400"/>
+              </a:spcAft>
+            </a:pPr>
+            <a:r>
+              <a:rPr sz="2400" b="0">
+                <a:solidFill>
+                  <a:srgbClr val="1A1410"/>
+                </a:solidFill>
+                <a:latin typeface="Segoe UI"/>
+              </a:rPr>
+              <a:t>📅</a:t>
+            </a:r>
+          </a:p>
+        </p:txBody>
+      </p:sp>
+      <p:sp>
+        <p:nvSpPr>
+          <p:cNvPr id="10" name="TextBox 9"/>
+          <p:cNvSpPr txBox="1"/>
+          <p:nvPr/>
+        </p:nvSpPr>
+        <p:spPr>
+          <a:xfrm>
+            <a:off x="978408" y="3675887"/>
+            <a:ext cx="1600200" cy="384048"/>
+          </a:xfrm>
+          <a:prstGeom prst="rect">
+            <a:avLst/>
+          </a:prstGeom>
+          <a:noFill/>
+        </p:spPr>
+        <p:txBody>
+          <a:bodyPr wrap="square" anchor="ctr" lIns="0" rIns="0" tIns="0" bIns="0">
+            <a:spAutoFit/>
+          </a:bodyPr>
+          <a:lstStyle/>
+          <a:p>
+            <a:pPr algn="l">
+              <a:lnSpc>
+                <a:spcPct val="100000"/>
+              </a:lnSpc>
+              <a:spcBef>
+                <a:spcPts val="0"/>
+              </a:spcBef>
+              <a:spcAft>
+                <a:spcPts val="400"/>
+              </a:spcAft>
+            </a:pPr>
+            <a:r>
+              <a:rPr sz="1450" b="1">
+                <a:solidFill>
+                  <a:srgbClr val="1A1410"/>
+                </a:solidFill>
+                <a:latin typeface="Segoe UI"/>
+              </a:rPr>
+              <a:t>Oylik obuna</a:t>
+            </a:r>
+          </a:p>
+        </p:txBody>
+      </p:sp>
+      <p:sp>
+        <p:nvSpPr>
+          <p:cNvPr id="11" name="Rounded Rectangle 10"/>
+          <p:cNvSpPr/>
+          <p:nvPr/>
+        </p:nvSpPr>
+        <p:spPr>
+          <a:xfrm>
+            <a:off x="2331720" y="3712463"/>
+            <a:ext cx="960120" cy="329184"/>
+          </a:xfrm>
+          <a:prstGeom prst="roundRect">
+            <a:avLst>
+              <a:gd name="adj" fmla="val 9000"/>
+            </a:avLst>
+          </a:prstGeom>
+          <a:solidFill>
+            <a:srgbClr val="FFEEE4"/>
+          </a:solidFill>
+          <a:ln>
+            <a:noFill/>
+          </a:ln>
+          <a:effectLst/>
+        </p:spPr>
+        <p:style>
+          <a:lnRef idx="1">
+            <a:schemeClr val="accent1"/>
+          </a:lnRef>
+          <a:fillRef idx="3">
+            <a:schemeClr val="accent1"/>
+          </a:fillRef>
+          <a:effectRef idx="2">
+            <a:schemeClr val="accent1"/>
+          </a:effectRef>
+          <a:fontRef idx="minor">
+            <a:schemeClr val="lt1"/>
+          </a:fontRef>
+        </p:style>
+        <p:txBody>
+          <a:bodyPr rtlCol="0" anchor="ctr"/>
+          <a:lstStyle/>
+          <a:p>
+            <a:pPr algn="ctr"/>
+            <a:r>
+              <a:rPr sz="850" b="1">
+                <a:solidFill>
+                  <a:srgbClr val="D64815"/>
+                </a:solidFill>
+                <a:latin typeface="Segoe UI"/>
+              </a:rPr>
+              <a:t>ASOSIY</a:t>
+            </a:r>
+          </a:p>
+        </p:txBody>
+      </p:sp>
+      <p:sp>
+        <p:nvSpPr>
+          <p:cNvPr id="12" name="TextBox 11"/>
+          <p:cNvSpPr txBox="1"/>
+          <p:nvPr/>
+        </p:nvSpPr>
+        <p:spPr>
+          <a:xfrm>
+            <a:off x="978408" y="4160520"/>
+            <a:ext cx="2880360" cy="1280160"/>
+          </a:xfrm>
+          <a:prstGeom prst="rect">
+            <a:avLst/>
+          </a:prstGeom>
+          <a:noFill/>
+        </p:spPr>
+        <p:txBody>
+          <a:bodyPr wrap="square" anchor="t" lIns="0" rIns="0" tIns="0" bIns="0">
+            <a:spAutoFit/>
+          </a:bodyPr>
+          <a:lstStyle/>
+          <a:p>
+            <a:pPr algn="l">
+              <a:lnSpc>
+                <a:spcPct val="115000"/>
+              </a:lnSpc>
+              <a:spcBef>
+                <a:spcPts val="0"/>
+              </a:spcBef>
+              <a:spcAft>
+                <a:spcPts val="400"/>
+              </a:spcAft>
+            </a:pPr>
+            <a:r>
+              <a:rPr sz="1100" b="0">
+                <a:solidFill>
+                  <a:srgbClr val="6B6259"/>
+                </a:solidFill>
+                <a:latin typeface="Segoe UI"/>
+              </a:rPr>
+              <a:t>Har ovqatlanish joyi platformada bo'lish uchun oylik to'laydi. Tier $20–150/oy — ko'rinish, bron paneli, analitika. Barqaror daromad.</a:t>
+            </a:r>
+          </a:p>
+        </p:txBody>
+      </p:sp>
+      <p:sp>
+        <p:nvSpPr>
+          <p:cNvPr id="13" name="Rounded Rectangle 12"/>
+          <p:cNvSpPr/>
+          <p:nvPr/>
+        </p:nvSpPr>
+        <p:spPr>
+          <a:xfrm>
+            <a:off x="4434840" y="2926080"/>
+            <a:ext cx="3429000" cy="2606040"/>
           </a:xfrm>
           <a:prstGeom prst="roundRect">
             <a:avLst>
@@ -13033,13 +13325,13 @@
       </p:sp>
       <p:sp>
         <p:nvSpPr>
-          <p:cNvPr id="9" name="TextBox 8"/>
-          <p:cNvSpPr txBox="1"/>
-          <p:nvPr/>
-        </p:nvSpPr>
-        <p:spPr>
-          <a:xfrm>
-            <a:off x="978408" y="3182112"/>
+          <p:cNvPr id="14" name="TextBox 13"/>
+          <p:cNvSpPr txBox="1"/>
+          <p:nvPr/>
+        </p:nvSpPr>
+        <p:spPr>
+          <a:xfrm>
+            <a:off x="4727448" y="3182112"/>
             <a:ext cx="2880360" cy="457200"/>
           </a:xfrm>
           <a:prstGeom prst="rect">
@@ -13078,13 +13370,13 @@
       </p:sp>
       <p:sp>
         <p:nvSpPr>
-          <p:cNvPr id="10" name="TextBox 9"/>
-          <p:cNvSpPr txBox="1"/>
-          <p:nvPr/>
-        </p:nvSpPr>
-        <p:spPr>
-          <a:xfrm>
-            <a:off x="978408" y="3730752"/>
+          <p:cNvPr id="15" name="TextBox 14"/>
+          <p:cNvSpPr txBox="1"/>
+          <p:nvPr/>
+        </p:nvSpPr>
+        <p:spPr>
+          <a:xfrm>
+            <a:off x="4727448" y="3730752"/>
             <a:ext cx="2880360" cy="457200"/>
           </a:xfrm>
           <a:prstGeom prst="rect">
@@ -13116,21 +13408,21 @@
                 </a:solidFill>
                 <a:latin typeface="Segoe UI"/>
               </a:rPr>
-              <a:t>Bron komissiya</a:t>
-            </a:r>
-          </a:p>
-        </p:txBody>
-      </p:sp>
-      <p:sp>
-        <p:nvSpPr>
-          <p:cNvPr id="11" name="TextBox 10"/>
-          <p:cNvSpPr txBox="1"/>
-          <p:nvPr/>
-        </p:nvSpPr>
-        <p:spPr>
-          <a:xfrm>
-            <a:off x="978408" y="4187952"/>
-            <a:ext cx="2880360" cy="1024128"/>
+              <a:t>Bron/zakaz komissiya</a:t>
+            </a:r>
+          </a:p>
+        </p:txBody>
+      </p:sp>
+      <p:sp>
+        <p:nvSpPr>
+          <p:cNvPr id="16" name="TextBox 15"/>
+          <p:cNvSpPr txBox="1"/>
+          <p:nvPr/>
+        </p:nvSpPr>
+        <p:spPr>
+          <a:xfrm>
+            <a:off x="4727448" y="4187952"/>
+            <a:ext cx="2880360" cy="1161288"/>
           </a:xfrm>
           <a:prstGeom prst="rect">
             <a:avLst/>
@@ -13161,21 +13453,21 @@
                 </a:solidFill>
                 <a:latin typeface="Segoe UI"/>
               </a:rPr>
-              <a:t>Har muvaffaqiyatli bron/zakaz uchun restorandan 3–8% yoki fiks to'lov.</a:t>
-            </a:r>
-          </a:p>
-        </p:txBody>
-      </p:sp>
-      <p:sp>
-        <p:nvSpPr>
-          <p:cNvPr id="12" name="Rounded Rectangle 11"/>
+              <a:t>Har muvaffaqiyatli bron/zakaz uchun qo'shimcha 3–8%. Obuna ustiga tranzaksion oqim.</a:t>
+            </a:r>
+          </a:p>
+        </p:txBody>
+      </p:sp>
+      <p:sp>
+        <p:nvSpPr>
+          <p:cNvPr id="17" name="Rounded Rectangle 16"/>
           <p:cNvSpPr/>
           <p:nvPr/>
         </p:nvSpPr>
         <p:spPr>
           <a:xfrm>
-            <a:off x="4434840" y="2926080"/>
-            <a:ext cx="3429000" cy="2468880"/>
+            <a:off x="8183879" y="2926080"/>
+            <a:ext cx="3429000" cy="2606040"/>
           </a:xfrm>
           <a:prstGeom prst="roundRect">
             <a:avLst>
@@ -13216,190 +13508,7 @@
       </p:sp>
       <p:sp>
         <p:nvSpPr>
-          <p:cNvPr id="13" name="TextBox 12"/>
-          <p:cNvSpPr txBox="1"/>
-          <p:nvPr/>
-        </p:nvSpPr>
-        <p:spPr>
-          <a:xfrm>
-            <a:off x="4727448" y="3182112"/>
-            <a:ext cx="2880360" cy="457200"/>
-          </a:xfrm>
-          <a:prstGeom prst="rect">
-            <a:avLst/>
-          </a:prstGeom>
-          <a:noFill/>
-        </p:spPr>
-        <p:txBody>
-          <a:bodyPr wrap="square" anchor="t" lIns="0" rIns="0" tIns="0" bIns="0">
-            <a:spAutoFit/>
-          </a:bodyPr>
-          <a:lstStyle/>
-          <a:p>
-            <a:pPr algn="l">
-              <a:lnSpc>
-                <a:spcPct val="100000"/>
-              </a:lnSpc>
-              <a:spcBef>
-                <a:spcPts val="0"/>
-              </a:spcBef>
-              <a:spcAft>
-                <a:spcPts val="400"/>
-              </a:spcAft>
-            </a:pPr>
-            <a:r>
-              <a:rPr sz="2400" b="0">
-                <a:solidFill>
-                  <a:srgbClr val="1A1410"/>
-                </a:solidFill>
-                <a:latin typeface="Segoe UI"/>
-              </a:rPr>
-              <a:t>⭐</a:t>
-            </a:r>
-          </a:p>
-        </p:txBody>
-      </p:sp>
-      <p:sp>
-        <p:nvSpPr>
-          <p:cNvPr id="14" name="TextBox 13"/>
-          <p:cNvSpPr txBox="1"/>
-          <p:nvPr/>
-        </p:nvSpPr>
-        <p:spPr>
-          <a:xfrm>
-            <a:off x="4727448" y="3730752"/>
-            <a:ext cx="2880360" cy="457200"/>
-          </a:xfrm>
-          <a:prstGeom prst="rect">
-            <a:avLst/>
-          </a:prstGeom>
-          <a:noFill/>
-        </p:spPr>
-        <p:txBody>
-          <a:bodyPr wrap="square" anchor="t" lIns="0" rIns="0" tIns="0" bIns="0">
-            <a:spAutoFit/>
-          </a:bodyPr>
-          <a:lstStyle/>
-          <a:p>
-            <a:pPr algn="l">
-              <a:lnSpc>
-                <a:spcPct val="100000"/>
-              </a:lnSpc>
-              <a:spcBef>
-                <a:spcPts val="0"/>
-              </a:spcBef>
-              <a:spcAft>
-                <a:spcPts val="400"/>
-              </a:spcAft>
-            </a:pPr>
-            <a:r>
-              <a:rPr sz="1550" b="1">
-                <a:solidFill>
-                  <a:srgbClr val="1A1410"/>
-                </a:solidFill>
-                <a:latin typeface="Segoe UI"/>
-              </a:rPr>
-              <a:t>Premium listing</a:t>
-            </a:r>
-          </a:p>
-        </p:txBody>
-      </p:sp>
-      <p:sp>
-        <p:nvSpPr>
-          <p:cNvPr id="15" name="TextBox 14"/>
-          <p:cNvSpPr txBox="1"/>
-          <p:nvPr/>
-        </p:nvSpPr>
-        <p:spPr>
-          <a:xfrm>
-            <a:off x="4727448" y="4187952"/>
-            <a:ext cx="2880360" cy="1024128"/>
-          </a:xfrm>
-          <a:prstGeom prst="rect">
-            <a:avLst/>
-          </a:prstGeom>
-          <a:noFill/>
-        </p:spPr>
-        <p:txBody>
-          <a:bodyPr wrap="square" anchor="t" lIns="0" rIns="0" tIns="0" bIns="0">
-            <a:spAutoFit/>
-          </a:bodyPr>
-          <a:lstStyle/>
-          <a:p>
-            <a:pPr algn="l">
-              <a:lnSpc>
-                <a:spcPct val="115000"/>
-              </a:lnSpc>
-              <a:spcBef>
-                <a:spcPts val="0"/>
-              </a:spcBef>
-              <a:spcAft>
-                <a:spcPts val="400"/>
-              </a:spcAft>
-            </a:pPr>
-            <a:r>
-              <a:rPr sz="1150" b="0">
-                <a:solidFill>
-                  <a:srgbClr val="6B6259"/>
-                </a:solidFill>
-                <a:latin typeface="Segoe UI"/>
-              </a:rPr>
-              <a:t>Restoranlar uchun oylik obuna — yuqori ko'rinish, analitika, promo. $30–100/oy.</a:t>
-            </a:r>
-          </a:p>
-        </p:txBody>
-      </p:sp>
-      <p:sp>
-        <p:nvSpPr>
-          <p:cNvPr id="16" name="Rounded Rectangle 15"/>
-          <p:cNvSpPr/>
-          <p:nvPr/>
-        </p:nvSpPr>
-        <p:spPr>
-          <a:xfrm>
-            <a:off x="8183879" y="2926080"/>
-            <a:ext cx="3429000" cy="2468880"/>
-          </a:xfrm>
-          <a:prstGeom prst="roundRect">
-            <a:avLst>
-              <a:gd name="adj" fmla="val 9000"/>
-            </a:avLst>
-          </a:prstGeom>
-          <a:solidFill>
-            <a:srgbClr val="FFFFFF"/>
-          </a:solidFill>
-          <a:ln w="12700">
-            <a:solidFill>
-              <a:srgbClr val="E4DDD2"/>
-            </a:solidFill>
-          </a:ln>
-          <a:effectLst/>
-        </p:spPr>
-        <p:style>
-          <a:lnRef idx="1">
-            <a:schemeClr val="accent1"/>
-          </a:lnRef>
-          <a:fillRef idx="3">
-            <a:schemeClr val="accent1"/>
-          </a:fillRef>
-          <a:effectRef idx="2">
-            <a:schemeClr val="accent1"/>
-          </a:effectRef>
-          <a:fontRef idx="minor">
-            <a:schemeClr val="lt1"/>
-          </a:fontRef>
-        </p:style>
-        <p:txBody>
-          <a:bodyPr rtlCol="0" anchor="ctr"/>
-          <a:lstStyle/>
-          <a:p>
-            <a:pPr algn="ctr"/>
-          </a:p>
-        </p:txBody>
-      </p:sp>
-      <p:sp>
-        <p:nvSpPr>
-          <p:cNvPr id="17" name="TextBox 16"/>
+          <p:cNvPr id="18" name="TextBox 17"/>
           <p:cNvSpPr txBox="1"/>
           <p:nvPr/>
         </p:nvSpPr>
@@ -13444,7 +13553,7 @@
       </p:sp>
       <p:sp>
         <p:nvSpPr>
-          <p:cNvPr id="18" name="TextBox 17"/>
+          <p:cNvPr id="19" name="TextBox 18"/>
           <p:cNvSpPr txBox="1"/>
           <p:nvPr/>
         </p:nvSpPr>
@@ -13489,14 +13598,14 @@
       </p:sp>
       <p:sp>
         <p:nvSpPr>
-          <p:cNvPr id="19" name="TextBox 18"/>
+          <p:cNvPr id="20" name="TextBox 19"/>
           <p:cNvSpPr txBox="1"/>
           <p:nvPr/>
         </p:nvSpPr>
         <p:spPr>
           <a:xfrm>
             <a:off x="8476488" y="4187952"/>
-            <a:ext cx="2880360" cy="1024128"/>
+            <a:ext cx="2880360" cy="1161288"/>
           </a:xfrm>
           <a:prstGeom prst="rect">
             <a:avLst/>
@@ -13527,20 +13636,20 @@
                 </a:solidFill>
                 <a:latin typeface="Segoe UI"/>
               </a:rPr>
-              <a:t>Keyin: POS integratsiya, talab analitikasi, reklama. Yuqori marjali qatlam.</a:t>
-            </a:r>
-          </a:p>
-        </p:txBody>
-      </p:sp>
-      <p:sp>
-        <p:nvSpPr>
-          <p:cNvPr id="20" name="TextBox 19"/>
-          <p:cNvSpPr txBox="1"/>
-          <p:nvPr/>
-        </p:nvSpPr>
-        <p:spPr>
-          <a:xfrm>
-            <a:off x="685800" y="5669280"/>
+              <a:t>Keyin: POS integratsiya, talab analitikasi, reklama. Yuqori marjali kengayish qatlami.</a:t>
+            </a:r>
+          </a:p>
+        </p:txBody>
+      </p:sp>
+      <p:sp>
+        <p:nvSpPr>
+          <p:cNvPr id="21" name="TextBox 20"/>
+          <p:cNvSpPr txBox="1"/>
+          <p:nvPr/>
+        </p:nvSpPr>
+        <p:spPr>
+          <a:xfrm>
+            <a:off x="685800" y="5806440"/>
             <a:ext cx="10789920" cy="731520"/>
           </a:xfrm>
           <a:prstGeom prst="rect">
@@ -13572,7 +13681,7 @@
                 </a:solidFill>
                 <a:latin typeface="Segoe UI"/>
               </a:rPr>
-              <a:t>Dastavka — hamkor kuryer (Yandex/Uzum) orqali. Biz og'ir logistikaga kirmaymiz — </a:t>
+              <a:t>Barcha ovqatlanish joylari — restoran, kafe, choyxona, oshxona, fastfud. Dastavka — hamkor kuryer (Yandex/Uzum). </a:t>
             </a:r>
             <a:r>
               <a:rPr sz="1200" b="1">
@@ -13581,23 +13690,14 @@
                 </a:solidFill>
                 <a:latin typeface="Segoe UI"/>
               </a:rPr>
-              <a:t>zakaz + data bizda</a:t>
-            </a:r>
-            <a:r>
-              <a:rPr sz="1200" b="0">
-                <a:solidFill>
-                  <a:srgbClr val="6B6259"/>
-                </a:solidFill>
-                <a:latin typeface="Segoe UI"/>
-              </a:rPr>
-              <a:t>, yetkazish hamkorda.</a:t>
-            </a:r>
-          </a:p>
-        </p:txBody>
-      </p:sp>
-      <p:sp>
-        <p:nvSpPr>
-          <p:cNvPr id="21" name="Rectangle 20"/>
+              <a:t>Zakaz + data bizda.</a:t>
+            </a:r>
+          </a:p>
+        </p:txBody>
+      </p:sp>
+      <p:sp>
+        <p:nvSpPr>
+          <p:cNvPr id="22" name="Rectangle 21"/>
           <p:cNvSpPr/>
           <p:nvPr/>
         </p:nvSpPr>
@@ -14485,7 +14585,7 @@
                 </a:solidFill>
                 <a:latin typeface="Segoe UI"/>
               </a:rPr>
-              <a:t>Restoran onboarding</a:t>
+              <a:t>Ovqatlanish joyi onboarding</a:t>
             </a:r>
           </a:p>
         </p:txBody>

</xml_diff>